<commit_message>
docs: refresh template-driven materials
</commit_message>
<xml_diff>
--- a/docs/business-overview-deck/output/bill_verification_business_overview_editable.pptx
+++ b/docs/business-overview-deck/output/bill_verification_business_overview_editable.pptx
@@ -3172,7 +3172,7 @@
                 <a:ea typeface="Microsoft YaHei"/>
                 <a:cs typeface="Microsoft YaHei"/>
               </a:rPr>
-              <a:t>构建权签票据一致性 AI 预审能力</a:t>
+              <a:t>构建模板字段驱动的权签票据 AI 预审能力</a:t>
             </a:r>
           </a:p>
         </p:txBody>
@@ -3254,7 +3254,7 @@
                 <a:ea typeface="Microsoft YaHei"/>
                 <a:cs typeface="Microsoft YaHei"/>
               </a:rPr>
-              <a:t>核心判断：将票面信息抽取、字段映射、风险核验和人工反馈拉通为端到端闭环，辅助权签人聚焦高风险差异。</a:t>
+              <a:t>核心判断：业务先定义当前模板要核验哪些系统字段，AI 按字段清单定向提取，系统再用别名规则补映射并提示风险。</a:t>
             </a:r>
           </a:p>
         </p:txBody>
@@ -3371,7 +3371,7 @@
                 <a:ea typeface="Microsoft YaHei"/>
                 <a:cs typeface="Microsoft YaHei"/>
               </a:rPr>
-              <a:t>1. 票面文档输入</a:t>
+              <a:t>1. 选择核验模板</a:t>
             </a:r>
           </a:p>
         </p:txBody>
@@ -3408,7 +3408,7 @@
                 <a:ea typeface="Microsoft YaHei"/>
                 <a:cs typeface="Microsoft YaHei"/>
               </a:rPr>
-              <a:t>支票 / 转账信 / 汇款申请书</a:t>
+              <a:t>带出本次待检查系统字段</a:t>
             </a:r>
           </a:p>
         </p:txBody>
@@ -3525,7 +3525,7 @@
                 <a:ea typeface="Microsoft YaHei"/>
                 <a:cs typeface="Microsoft YaHei"/>
               </a:rPr>
-              <a:t>2. AI 原文抽取</a:t>
+              <a:t>2. AI 定向提取</a:t>
             </a:r>
           </a:p>
         </p:txBody>
@@ -3562,7 +3562,7 @@
                 <a:ea typeface="Microsoft YaHei"/>
                 <a:cs typeface="Microsoft YaHei"/>
               </a:rPr>
-              <a:t>输出 document_items，保留票面 Key/Value 原文</a:t>
+              <a:t>输出 document_items / extracted_fields</a:t>
             </a:r>
           </a:p>
         </p:txBody>
@@ -3679,7 +3679,7 @@
                 <a:ea typeface="Microsoft YaHei"/>
                 <a:cs typeface="Microsoft YaHei"/>
               </a:rPr>
-              <a:t>3. 规则字段映射</a:t>
+              <a:t>3. 别名补映射</a:t>
             </a:r>
           </a:p>
         </p:txBody>
@@ -3716,7 +3716,7 @@
                 <a:ea typeface="Microsoft YaHei"/>
                 <a:cs typeface="Microsoft YaHei"/>
               </a:rPr>
-              <a:t>模板别名 + 字段规则 + AI 候选映射</a:t>
+              <a:t>模板别名规则兜底生成字段映射</a:t>
             </a:r>
           </a:p>
         </p:txBody>
@@ -3833,7 +3833,7 @@
                 <a:ea typeface="Microsoft YaHei"/>
                 <a:cs typeface="Microsoft YaHei"/>
               </a:rPr>
-              <a:t>4. 一致性核验</a:t>
+              <a:t>4. 函数包核验</a:t>
             </a:r>
           </a:p>
         </p:txBody>
@@ -4024,7 +4024,7 @@
                 <a:ea typeface="Microsoft YaHei"/>
                 <a:cs typeface="Microsoft YaHei"/>
               </a:rPr>
-              <a:t>人工聚焦风险并提交优化反馈</a:t>
+              <a:t>聚焦风险并沉淀优化反馈</a:t>
             </a:r>
           </a:p>
         </p:txBody>
@@ -4434,7 +4434,7 @@
                 <a:ea typeface="Microsoft YaHei"/>
                 <a:cs typeface="Microsoft YaHei"/>
               </a:rPr>
-              <a:t>票面原文抽取、字段映射、风险规则、反馈沉淀</a:t>
+              <a:t>模板字段清单、票面原文、系统映射、风险结果</a:t>
             </a:r>
           </a:p>
         </p:txBody>
@@ -4516,7 +4516,7 @@
                 <a:ea typeface="Microsoft YaHei"/>
                 <a:cs typeface="Microsoft YaHei"/>
               </a:rPr>
-              <a:t>降低人工逐项肉眼核对压力，提升问题聚焦效率</a:t>
+              <a:t>让权签人先看风险项，而不是逐字肉眼遍历票面</a:t>
             </a:r>
           </a:p>
         </p:txBody>
@@ -4680,7 +4680,7 @@
                 <a:ea typeface="Microsoft YaHei"/>
                 <a:cs typeface="Microsoft YaHei"/>
               </a:rPr>
-              <a:t>模板别名、位置提示、规则边界、样本反馈</a:t>
+              <a:t>模板新增/复制、字段增删改、别名、位置提示、反馈样本</a:t>
             </a:r>
           </a:p>
         </p:txBody>
@@ -4762,7 +4762,7 @@
                 <a:ea typeface="Microsoft YaHei"/>
                 <a:cs typeface="Microsoft YaHei"/>
               </a:rPr>
-              <a:t>让能力不依赖频繁发版，支持持续迭代</a:t>
+              <a:t>让字段叫法和模板差异通过配置持续迭代</a:t>
             </a:r>
           </a:p>
         </p:txBody>
@@ -4881,7 +4881,7 @@
                 <a:ea typeface="Microsoft YaHei"/>
                 <a:cs typeface="Microsoft YaHei"/>
               </a:rPr>
-              <a:t>本项目定位为权签前风险初筛能力，不替代权签人最终判断，而是构建可运营、可解释、可迭代的预审底座。</a:t>
+              <a:t>最新方案把“该提什么”前移到模板配置，把“怎么映射”落实为 Prompt 辅助 + 后端规则兜底。</a:t>
             </a:r>
           </a:p>
         </p:txBody>
@@ -7113,7 +7113,7 @@
                 <a:ea typeface="Microsoft YaHei"/>
                 <a:cs typeface="Microsoft YaHei"/>
               </a:rPr>
-              <a:t>将模型能力拆分为原文抽取与字段映射两层</a:t>
+              <a:t>将 AI 预审拆成字段配置、模型提取和规则补映射</a:t>
             </a:r>
           </a:p>
         </p:txBody>
@@ -7195,7 +7195,7 @@
                 <a:ea typeface="Microsoft YaHei"/>
                 <a:cs typeface="Microsoft YaHei"/>
               </a:rPr>
-              <a:t>核心判断：模型负责看懂票面并输出证据，系统负责可解释映射和一致性判断，避免模型直接替代业务规则。</a:t>
+              <a:t>核心判断：模型负责看图和提取候选，系统负责限定字段范围、补足别名映射和保留可解释证据链。</a:t>
             </a:r>
           </a:p>
         </p:txBody>
@@ -7722,7 +7722,7 @@
                 <a:ea typeface="Microsoft YaHei"/>
                 <a:cs typeface="Microsoft YaHei"/>
               </a:rPr>
-              <a:t>1. 票面原文抽取</a:t>
+              <a:t>1. 模板字段配置</a:t>
             </a:r>
           </a:p>
         </p:txBody>
@@ -7804,7 +7804,7 @@
                 <a:ea typeface="Microsoft YaHei"/>
                 <a:cs typeface="Microsoft YaHei"/>
               </a:rPr>
-              <a:t>票面图片 / 截图 / 扫描件</a:t>
+              <a:t>银行/国家/单据模板 + MAP 字段</a:t>
             </a:r>
           </a:p>
         </p:txBody>
@@ -7886,7 +7886,7 @@
                 <a:ea typeface="Microsoft YaHei"/>
                 <a:cs typeface="Microsoft YaHei"/>
               </a:rPr>
-              <a:t>原始 Key、Value、位置证据</a:t>
+              <a:t>待检查字段、含义、别名、位置提示</a:t>
             </a:r>
           </a:p>
         </p:txBody>
@@ -7968,7 +7968,7 @@
                 <a:ea typeface="Microsoft YaHei"/>
                 <a:cs typeface="Microsoft YaHei"/>
               </a:rPr>
-              <a:t>提示词约束保留原文，不翻译、不补全</a:t>
+              <a:t>只有发布模板才启动 AI</a:t>
             </a:r>
           </a:p>
         </p:txBody>
@@ -8050,7 +8050,7 @@
                 <a:ea typeface="Microsoft YaHei"/>
                 <a:cs typeface="Microsoft YaHei"/>
               </a:rPr>
-              <a:t>模型改写票面文字或幻觉补字段</a:t>
+              <a:t>未配置模板无法进入预审</a:t>
             </a:r>
           </a:p>
         </p:txBody>
@@ -8132,7 +8132,7 @@
                 <a:ea typeface="Microsoft YaHei"/>
                 <a:cs typeface="Microsoft YaHei"/>
               </a:rPr>
-              <a:t>2. 字段映射</a:t>
+              <a:t>2. 模型定向提取</a:t>
             </a:r>
           </a:p>
         </p:txBody>
@@ -8214,7 +8214,7 @@
                 <a:ea typeface="Microsoft YaHei"/>
                 <a:cs typeface="Microsoft YaHei"/>
               </a:rPr>
-              <a:t>票面原文 + 模板规则 + 系统字段字典</a:t>
+              <a:t>票面图片 + 当前模板字段清单</a:t>
             </a:r>
           </a:p>
         </p:txBody>
@@ -8296,7 +8296,7 @@
                 <a:ea typeface="Microsoft YaHei"/>
                 <a:cs typeface="Microsoft YaHei"/>
               </a:rPr>
-              <a:t>标准字段、原始标签、原始取值、映射来源</a:t>
+              <a:t>双层 JSON 结果</a:t>
             </a:r>
           </a:p>
         </p:txBody>
@@ -8378,7 +8378,7 @@
                 <a:ea typeface="Microsoft YaHei"/>
                 <a:cs typeface="Microsoft YaHei"/>
               </a:rPr>
-              <a:t>别名规则优先，AI 候选辅助</a:t>
+              <a:t>Prompt 要求保留原文并限制字段集合</a:t>
             </a:r>
           </a:p>
         </p:txBody>
@@ -8460,7 +8460,7 @@
                 <a:ea typeface="Microsoft YaHei"/>
                 <a:cs typeface="Microsoft YaHei"/>
               </a:rPr>
-              <a:t>别名泛化过度导致误映射</a:t>
+              <a:t>模型只返回原文但漏掉字段映射</a:t>
             </a:r>
           </a:p>
         </p:txBody>
@@ -8542,7 +8542,7 @@
                 <a:ea typeface="Microsoft YaHei"/>
                 <a:cs typeface="Microsoft YaHei"/>
               </a:rPr>
-              <a:t>3. 规则核验</a:t>
+              <a:t>3. 后端补映射</a:t>
             </a:r>
           </a:p>
         </p:txBody>
@@ -8624,7 +8624,7 @@
                 <a:ea typeface="Microsoft YaHei"/>
                 <a:cs typeface="Microsoft YaHei"/>
               </a:rPr>
-              <a:t>系统支付指令 + 标准字段</a:t>
+              <a:t>document_items + 模板别名</a:t>
             </a:r>
           </a:p>
         </p:txBody>
@@ -8706,7 +8706,7 @@
                 <a:ea typeface="Microsoft YaHei"/>
                 <a:cs typeface="Microsoft YaHei"/>
               </a:rPr>
-              <a:t>风险等级、差异说明、通过项</a:t>
+              <a:t>mapped_field、系统来源字段、mapping_source</a:t>
             </a:r>
           </a:p>
         </p:txBody>
@@ -8788,7 +8788,7 @@
                 <a:ea typeface="Microsoft YaHei"/>
                 <a:cs typeface="Microsoft YaHei"/>
               </a:rPr>
-              <a:t>金额、账号、币种、日期等规则化比对</a:t>
+              <a:t>别名规则按模板范围确定性生效</a:t>
             </a:r>
           </a:p>
         </p:txBody>
@@ -8870,7 +8870,7 @@
                 <a:ea typeface="Microsoft YaHei"/>
                 <a:cs typeface="Microsoft YaHei"/>
               </a:rPr>
-              <a:t>通过项过多干扰权签人阅读</a:t>
+              <a:t>别名过宽导致误映射</a:t>
             </a:r>
           </a:p>
         </p:txBody>
@@ -8952,7 +8952,7 @@
                 <a:ea typeface="Microsoft YaHei"/>
                 <a:cs typeface="Microsoft YaHei"/>
               </a:rPr>
-              <a:t>4. 反馈沉淀</a:t>
+              <a:t>4. 规则核验</a:t>
             </a:r>
           </a:p>
         </p:txBody>
@@ -9034,7 +9034,7 @@
                 <a:ea typeface="Microsoft YaHei"/>
                 <a:cs typeface="Microsoft YaHei"/>
               </a:rPr>
-              <a:t>人工确认、纠错、忽略、提交优化</a:t>
+              <a:t>系统支付指令 + 标准字段</a:t>
             </a:r>
           </a:p>
         </p:txBody>
@@ -9116,7 +9116,7 @@
                 <a:ea typeface="Microsoft YaHei"/>
                 <a:cs typeface="Microsoft YaHei"/>
               </a:rPr>
-              <a:t>模板别名、样本记录、调优建议</a:t>
+              <a:t>风险项、通过项、证据和置信度</a:t>
             </a:r>
           </a:p>
         </p:txBody>
@@ -9198,7 +9198,7 @@
                 <a:ea typeface="Microsoft YaHei"/>
                 <a:cs typeface="Microsoft YaHei"/>
               </a:rPr>
-              <a:t>按模板和字段范围生效</a:t>
+              <a:t>MAP/交易系统函数包负责最终比对</a:t>
             </a:r>
           </a:p>
         </p:txBody>
@@ -9280,7 +9280,7 @@
                 <a:ea typeface="Microsoft YaHei"/>
                 <a:cs typeface="Microsoft YaHei"/>
               </a:rPr>
-              <a:t>跨模板配置污染</a:t>
+              <a:t>比对规则归属不清</a:t>
             </a:r>
           </a:p>
         </p:txBody>
@@ -9399,7 +9399,7 @@
                 <a:ea typeface="Microsoft YaHei"/>
                 <a:cs typeface="Microsoft YaHei"/>
               </a:rPr>
-              <a:t>当前设计的关键不是让模型“猜最终字段”，而是让系统能够解释“票面写了什么、映射成什么、为什么提示风险”。</a:t>
+              <a:t>当前设计要求 JSON 同时回答三件事：票面写了什么、对应哪个系统字段、这个映射来自模型还是模板别名规则。</a:t>
             </a:r>
           </a:p>
         </p:txBody>
@@ -9536,7 +9536,7 @@
                 <a:ea typeface="Microsoft YaHei"/>
                 <a:cs typeface="Microsoft YaHei"/>
               </a:rPr>
-              <a:t>在付款核验主流程中完成反馈闭环</a:t>
+              <a:t>核验页从“选择模板”开始逐字段输出预审结果</a:t>
             </a:r>
           </a:p>
         </p:txBody>
@@ -9618,7 +9618,7 @@
                 <a:ea typeface="Microsoft YaHei"/>
                 <a:cs typeface="Microsoft YaHei"/>
               </a:rPr>
-              <a:t>核心判断：反馈不应脱离业务流程单独存在，而应从一次真实预审风险出发，沉淀为当前模板下的可复用规则。</a:t>
+              <a:t>核心判断：权签人进入页面先看到模板字段清单，AI 预审后每个待检查系统字段都有提取结果或风险提示。</a:t>
             </a:r>
           </a:p>
         </p:txBody>
@@ -9735,7 +9735,7 @@
                 <a:ea typeface="Microsoft YaHei"/>
                 <a:cs typeface="Microsoft YaHei"/>
               </a:rPr>
-              <a:t>1. 选择付款任务</a:t>
+              <a:t>1. 选择模板</a:t>
             </a:r>
           </a:p>
         </p:txBody>
@@ -9772,8 +9772,8 @@
                 <a:ea typeface="Microsoft YaHei"/>
                 <a:cs typeface="Microsoft YaHei"/>
               </a:rPr>
-              <a:t>系统指令 + 票面文件
-模板由系统带出或人工修正</a:t>
+              <a:t>展示待检查系统字段
+样例任务可自动带出模板</a:t>
             </a:r>
           </a:p>
         </p:txBody>
@@ -9890,7 +9890,7 @@
                 <a:ea typeface="Microsoft YaHei"/>
                 <a:cs typeface="Microsoft YaHei"/>
               </a:rPr>
-              <a:t>2. 启动 AI 预审</a:t>
+              <a:t>2. 输入任务</a:t>
             </a:r>
           </a:p>
         </p:txBody>
@@ -9927,8 +9927,8 @@
                 <a:ea typeface="Microsoft YaHei"/>
                 <a:cs typeface="Microsoft YaHei"/>
               </a:rPr>
-              <a:t>真实调用多模态模型
-抽取票面原文</a:t>
+              <a:t>系统支付指令 + 票面文件
+并列预览</a:t>
             </a:r>
           </a:p>
         </p:txBody>
@@ -10045,7 +10045,7 @@
                 <a:ea typeface="Microsoft YaHei"/>
                 <a:cs typeface="Microsoft YaHei"/>
               </a:rPr>
-              <a:t>3. 展示风险结果</a:t>
+              <a:t>3. AI 逐字段提取</a:t>
             </a:r>
           </a:p>
         </p:txBody>
@@ -10082,8 +10082,8 @@
                 <a:ea typeface="Microsoft YaHei"/>
                 <a:cs typeface="Microsoft YaHei"/>
               </a:rPr>
-              <a:t>风险项展开
-通过项默认收起</a:t>
+              <a:t>字段有值则展示证据
+未提取则标记风险</a:t>
             </a:r>
           </a:p>
         </p:txBody>
@@ -10885,7 +10885,7 @@
                 <a:ea typeface="Microsoft YaHei"/>
                 <a:cs typeface="Microsoft YaHei"/>
               </a:rPr>
-              <a:t>模型识别出“入账行”，但未正确映射到收款方银行字段</a:t>
+              <a:t>原文有“入账行”，但结构化结果没有收款方银行字段</a:t>
             </a:r>
           </a:p>
         </p:txBody>
@@ -11049,7 +11049,7 @@
                 <a:ea typeface="Microsoft YaHei"/>
                 <a:cs typeface="Microsoft YaHei"/>
               </a:rPr>
-              <a:t>再次预审后风险消失或降级</a:t>
+              <a:t>后端补出 mapped_field，再次预审后风险消失或降级</a:t>
             </a:r>
           </a:p>
         </p:txBody>
@@ -11168,7 +11168,7 @@
                 <a:ea typeface="Microsoft YaHei"/>
                 <a:cs typeface="Microsoft YaHei"/>
               </a:rPr>
-              <a:t>业务用户看到的是一次完整核验旅程，产品侧沉淀的是可复用模板资产和高频问题样本。</a:t>
+              <a:t>业务用户看到的是逐字段风险闭环，产品侧沉淀的是模板字段、别名规则和可复用反馈样本。</a:t>
             </a:r>
           </a:p>
         </p:txBody>
@@ -11305,7 +11305,7 @@
                 <a:ea typeface="Microsoft YaHei"/>
                 <a:cs typeface="Microsoft YaHei"/>
               </a:rPr>
-              <a:t>以规则扩张为主、Prompt 辅助为辅控制映射边界</a:t>
+              <a:t>别名配置采用“Prompt 辅助 + 后端补映射”双通道生效</a:t>
             </a:r>
           </a:p>
         </p:txBody>
@@ -11387,7 +11387,7 @@
                 <a:ea typeface="Microsoft YaHei"/>
                 <a:cs typeface="Microsoft YaHei"/>
               </a:rPr>
-              <a:t>核心判断：别名配置不能简单堆进提示词，应通过规则明确生效范围，再让 Prompt 只补充当前模板必要上下文。</a:t>
+              <a:t>核心判断：业务改一个字段叫法后，既能帮助模型理解票面，也能让后端在模型漏映射时确定性补齐字段。</a:t>
             </a:r>
           </a:p>
         </p:txBody>
@@ -11504,7 +11504,7 @@
                 <a:ea typeface="Microsoft YaHei"/>
                 <a:cs typeface="Microsoft YaHei"/>
               </a:rPr>
-              <a:t>策略维度</a:t>
+              <a:t>配置项</a:t>
             </a:r>
           </a:p>
         </p:txBody>
@@ -11586,7 +11586,7 @@
                 <a:ea typeface="Microsoft YaHei"/>
                 <a:cs typeface="Microsoft YaHei"/>
               </a:rPr>
-              <a:t>不建议方式</a:t>
+              <a:t>进入 Prompt 的作用</a:t>
             </a:r>
           </a:p>
         </p:txBody>
@@ -11668,7 +11668,7 @@
                 <a:ea typeface="Microsoft YaHei"/>
                 <a:cs typeface="Microsoft YaHei"/>
               </a:rPr>
-              <a:t>推荐方式</a:t>
+              <a:t>进入后端规则的作用</a:t>
             </a:r>
           </a:p>
         </p:txBody>
@@ -11750,7 +11750,7 @@
                 <a:ea typeface="Microsoft YaHei"/>
                 <a:cs typeface="Microsoft YaHei"/>
               </a:rPr>
-              <a:t>原因</a:t>
+              <a:t>边界控制</a:t>
             </a:r>
           </a:p>
         </p:txBody>
@@ -11914,7 +11914,7 @@
                 <a:ea typeface="Microsoft YaHei"/>
                 <a:cs typeface="Microsoft YaHei"/>
               </a:rPr>
-              <a:t>把所有别名全部塞进 Prompt，让模型自由联想</a:t>
+              <a:t>告诉模型票面可能叫法，例如入账行</a:t>
             </a:r>
           </a:p>
         </p:txBody>
@@ -11996,7 +11996,7 @@
                 <a:ea typeface="Microsoft YaHei"/>
                 <a:cs typeface="Microsoft YaHei"/>
               </a:rPr>
-              <a:t>后端维护别名表，支持精确、包含、模糊等受控匹配</a:t>
+              <a:t>raw_key 命中别名时补系统字段映射</a:t>
             </a:r>
           </a:p>
         </p:txBody>
@@ -12078,7 +12078,7 @@
                 <a:ea typeface="Microsoft YaHei"/>
                 <a:cs typeface="Microsoft YaHei"/>
               </a:rPr>
-              <a:t>减少“出款方账户/账号/出款账号”之间的无边界泛化</a:t>
+              <a:t>限定在当前模板字段内</a:t>
             </a:r>
           </a:p>
         </p:txBody>
@@ -12160,7 +12160,7 @@
                 <a:ea typeface="Microsoft YaHei"/>
                 <a:cs typeface="Microsoft YaHei"/>
               </a:rPr>
-              <a:t>模板提示</a:t>
+              <a:t>业务含义</a:t>
             </a:r>
           </a:p>
         </p:txBody>
@@ -12242,7 +12242,7 @@
                 <a:ea typeface="Microsoft YaHei"/>
                 <a:cs typeface="Microsoft YaHei"/>
               </a:rPr>
-              <a:t>让 Prompt 承担全部模板规则</a:t>
+              <a:t>帮助模型区分相似字段，例如收款银行 vs 中间行</a:t>
             </a:r>
           </a:p>
         </p:txBody>
@@ -12324,7 +12324,7 @@
                 <a:ea typeface="Microsoft YaHei"/>
                 <a:cs typeface="Microsoft YaHei"/>
               </a:rPr>
-              <a:t>只写当前位置、票面习惯、特殊注意事项</a:t>
+              <a:t>不直接做规则匹配，只作为解释和审阅信息</a:t>
             </a:r>
           </a:p>
         </p:txBody>
@@ -12406,7 +12406,7 @@
                 <a:ea typeface="Microsoft YaHei"/>
                 <a:cs typeface="Microsoft YaHei"/>
               </a:rPr>
-              <a:t>让模型更好看图，但不替代系统规则</a:t>
+              <a:t>避免自然语言描述变成泛化规则</a:t>
             </a:r>
           </a:p>
         </p:txBody>
@@ -12488,7 +12488,7 @@
                 <a:ea typeface="Microsoft YaHei"/>
                 <a:cs typeface="Microsoft YaHei"/>
               </a:rPr>
-              <a:t>映射判断</a:t>
+              <a:t>位置提示</a:t>
             </a:r>
           </a:p>
         </p:txBody>
@@ -12570,7 +12570,7 @@
                 <a:ea typeface="Microsoft YaHei"/>
                 <a:cs typeface="Microsoft YaHei"/>
               </a:rPr>
-              <a:t>直接信任模型输出的 normalized_field</a:t>
+              <a:t>帮助模型在版面上找字段区域</a:t>
             </a:r>
           </a:p>
         </p:txBody>
@@ -12652,7 +12652,7 @@
                 <a:ea typeface="Microsoft YaHei"/>
                 <a:cs typeface="Microsoft YaHei"/>
               </a:rPr>
-              <a:t>模型给候选，系统结合规则和置信度最终落字段</a:t>
+              <a:t>不参与字段映射，只辅助证据判断</a:t>
             </a:r>
           </a:p>
         </p:txBody>
@@ -12734,7 +12734,7 @@
                 <a:ea typeface="Microsoft YaHei"/>
                 <a:cs typeface="Microsoft YaHei"/>
               </a:rPr>
-              <a:t>保证可解释、可回溯、可运营</a:t>
+              <a:t>避免位置配置污染其他模板</a:t>
             </a:r>
           </a:p>
         </p:txBody>
@@ -12816,7 +12816,7 @@
                 <a:ea typeface="Microsoft YaHei"/>
                 <a:cs typeface="Microsoft YaHei"/>
               </a:rPr>
-              <a:t>反馈生效</a:t>
+              <a:t>反馈优化</a:t>
             </a:r>
           </a:p>
         </p:txBody>
@@ -12898,7 +12898,7 @@
                 <a:ea typeface="Microsoft YaHei"/>
                 <a:cs typeface="Microsoft YaHei"/>
               </a:rPr>
-              <a:t>全局立即生效</a:t>
+              <a:t>下次调用模型时带入新叫法</a:t>
             </a:r>
           </a:p>
         </p:txBody>
@@ -12980,7 +12980,7 @@
                 <a:ea typeface="Microsoft YaHei"/>
                 <a:cs typeface="Microsoft YaHei"/>
               </a:rPr>
-              <a:t>按国家、银行、票据类型、模板版本限定范围</a:t>
+              <a:t>保存为模板别名或字段提示，支持回滚</a:t>
             </a:r>
           </a:p>
         </p:txBody>
@@ -13062,7 +13062,7 @@
                 <a:ea typeface="Microsoft YaHei"/>
                 <a:cs typeface="Microsoft YaHei"/>
               </a:rPr>
-              <a:t>避免不同模板间互相污染</a:t>
+              <a:t>按模板版本发布</a:t>
             </a:r>
           </a:p>
         </p:txBody>
@@ -13181,7 +13181,7 @@
                 <a:ea typeface="Microsoft YaHei"/>
                 <a:cs typeface="Microsoft YaHei"/>
               </a:rPr>
-              <a:t>配置体系的目标不是训练一个更会猜的模型，而是沉淀边界清晰、可解释、可回滚的规则资产。</a:t>
+              <a:t>配置体系不再只是“把词塞进 Prompt”，而是让业务配置同时约束模型输入和系统后处理。</a:t>
             </a:r>
           </a:p>
         </p:txBody>
@@ -14091,7 +14091,7 @@
                 <a:ea typeface="Microsoft YaHei"/>
                 <a:cs typeface="Microsoft YaHei"/>
               </a:rPr>
-              <a:t>选择任务、上传票面、启动 AI 预审、查看风险、提交优化</a:t>
+              <a:t>选择模板、查看字段清单、上传票面、启动 AI 预审、提交优化</a:t>
             </a:r>
           </a:p>
         </p:txBody>
@@ -14173,7 +14173,7 @@
                 <a:ea typeface="Microsoft YaHei"/>
                 <a:cs typeface="Microsoft YaHei"/>
               </a:rPr>
-              <a:t>系统指令与票面并列，风险项显性化</a:t>
+              <a:t>每个模板字段都有提取结果或风险提示</a:t>
             </a:r>
           </a:p>
         </p:txBody>
@@ -14501,7 +14501,7 @@
                 <a:ea typeface="Microsoft YaHei"/>
                 <a:cs typeface="Microsoft YaHei"/>
               </a:rPr>
-              <a:t>维护字段别名、位置提示、特殊条款、规则范围</a:t>
+              <a:t>新增/复制模板，增删改字段，维护别名、位置提示、提取要求</a:t>
             </a:r>
           </a:p>
         </p:txBody>
@@ -14665,7 +14665,7 @@
                 <a:ea typeface="Microsoft YaHei"/>
                 <a:cs typeface="Microsoft YaHei"/>
               </a:rPr>
-              <a:t>已具备雏形</a:t>
+              <a:t>已支持基础管理</a:t>
             </a:r>
           </a:p>
         </p:txBody>
@@ -16760,7 +16760,7 @@
                 <a:ea typeface="Microsoft YaHei"/>
                 <a:cs typeface="Microsoft YaHei"/>
               </a:rPr>
-              <a:t>Ordering Customer、Account With Institution、SWIFT、Charges</a:t>
+              <a:t>Ordering Customer、Bank、SWIFT</a:t>
             </a:r>
           </a:p>
         </p:txBody>
@@ -17918,7 +17918,7 @@
                 <a:ea typeface="Microsoft YaHei"/>
                 <a:cs typeface="Microsoft YaHei"/>
               </a:rPr>
-              <a:t>核心判断：当前 Demo 已验证关键链路，下一步应从可演示闭环走向可评估、可运营、可接入 MAP 的产品化路径。</a:t>
+              <a:t>核心判断：当前 Demo 已验证模板选择、真实模型提取、别名补映射、风险核验和反馈闭环，下一步应接入 MAP 配置与函数包。</a:t>
             </a:r>
           </a:p>
         </p:txBody>
@@ -18445,7 +18445,7 @@
                 <a:ea typeface="Microsoft YaHei"/>
                 <a:cs typeface="Microsoft YaHei"/>
               </a:rPr>
-              <a:t>打通真实模型、字段抽取、规则核验、反馈闭环</a:t>
+              <a:t>打通模板字段、模型提取、补映射、风险核验和反馈闭环</a:t>
             </a:r>
           </a:p>
         </p:txBody>
@@ -18527,7 +18527,7 @@
                 <a:ea typeface="Microsoft YaHei"/>
                 <a:cs typeface="Microsoft YaHei"/>
               </a:rPr>
-              <a:t>完善样例、修正页面旅程、沉淀文档和汇报材料</a:t>
+              <a:t>完善样例、刷新页面旅程、沉淀文档和汇报材料</a:t>
             </a:r>
           </a:p>
         </p:txBody>
@@ -18855,7 +18855,7 @@
                 <a:ea typeface="Microsoft YaHei"/>
                 <a:cs typeface="Microsoft YaHei"/>
               </a:rPr>
-              <a:t>建立模板识别、别名范围、特殊条款配置和反馈运营机制</a:t>
+              <a:t>建立模板选择、别名范围、特殊条款配置和反馈运营机制</a:t>
             </a:r>
           </a:p>
         </p:txBody>
@@ -19101,7 +19101,7 @@
                 <a:ea typeface="Microsoft YaHei"/>
                 <a:cs typeface="Microsoft YaHei"/>
               </a:rPr>
-              <a:t>由 MAP 管理系统字段、模板选择和转换规则</a:t>
+              <a:t>由 MAP 管理系统字段、模板发布和比对函数包</a:t>
             </a:r>
           </a:p>
         </p:txBody>

</xml_diff>

<commit_message>
feat: simplify AI field tuning inputs
</commit_message>
<xml_diff>
--- a/docs/business-overview-deck/output/bill_verification_business_overview_editable.pptx
+++ b/docs/business-overview-deck/output/bill_verification_business_overview_editable.pptx
@@ -4681,7 +4681,7 @@
                 <a:ea typeface="Microsoft YaHei"/>
                 <a:cs typeface="Microsoft YaHei"/>
               </a:rPr>
-              <a:t>模板新增/复制、字段增删改、别名、位置提示、反馈样本</a:t>
+              <a:t>模板新增/复制、字段增删改、票面别名、给 AI 的输入、反馈样本</a:t>
             </a:r>
           </a:p>
         </p:txBody>
@@ -7887,7 +7887,7 @@
                 <a:ea typeface="Microsoft YaHei"/>
                 <a:cs typeface="Microsoft YaHei"/>
               </a:rPr>
-              <a:t>待检查字段、含义、别名、位置提示</a:t>
+              <a:t>待检查字段、系统来源、票面别名、给 AI 的输入</a:t>
             </a:r>
           </a:p>
         </p:txBody>
@@ -10638,7 +10638,7 @@
                 <a:ea typeface="Microsoft YaHei"/>
                 <a:cs typeface="Microsoft YaHei"/>
               </a:rPr>
-              <a:t>模板字段、系统来源、别名、含义、位置提示</a:t>
+              <a:t>模板字段、系统来源、票面别名、给 AI 的输入</a:t>
             </a:r>
           </a:p>
         </p:txBody>
@@ -15404,7 +15404,7 @@
                 <a:ea typeface="Microsoft YaHei"/>
                 <a:cs typeface="Microsoft YaHei"/>
               </a:rPr>
-              <a:t>业务含义</a:t>
+              <a:t>给 AI 的输入</a:t>
             </a:r>
           </a:p>
         </p:txBody>
@@ -15486,7 +15486,7 @@
                 <a:ea typeface="Microsoft YaHei"/>
                 <a:cs typeface="Microsoft YaHei"/>
               </a:rPr>
-              <a:t>帮助模型区分相似字段，例如收款银行 vs 中间行</a:t>
+              <a:t>合并说明字段含义、常见位置和提取注意事项</a:t>
             </a:r>
           </a:p>
         </p:txBody>
@@ -15568,7 +15568,7 @@
                 <a:ea typeface="Microsoft YaHei"/>
                 <a:cs typeface="Microsoft YaHei"/>
               </a:rPr>
-              <a:t>不直接做规则匹配，只作为解释和审阅信息</a:t>
+              <a:t>不直接做规则匹配，只作为模型理解提示</a:t>
             </a:r>
           </a:p>
         </p:txBody>
@@ -15732,7 +15732,7 @@
                 <a:ea typeface="Microsoft YaHei"/>
                 <a:cs typeface="Microsoft YaHei"/>
               </a:rPr>
-              <a:t>位置提示</a:t>
+              <a:t>反馈优化</a:t>
             </a:r>
           </a:p>
         </p:txBody>
@@ -15814,7 +15814,7 @@
                 <a:ea typeface="Microsoft YaHei"/>
                 <a:cs typeface="Microsoft YaHei"/>
               </a:rPr>
-              <a:t>帮助模型在版面上找字段区域</a:t>
+              <a:t>下次调用模型时带入新叫法或更清晰的提取说明</a:t>
             </a:r>
           </a:p>
         </p:txBody>
@@ -15896,7 +15896,7 @@
                 <a:ea typeface="Microsoft YaHei"/>
                 <a:cs typeface="Microsoft YaHei"/>
               </a:rPr>
-              <a:t>不参与字段映射，只辅助证据判断</a:t>
+              <a:t>保存为模板别名或 AI 输入建议，支持回滚</a:t>
             </a:r>
           </a:p>
         </p:txBody>
@@ -15978,7 +15978,7 @@
                 <a:ea typeface="Microsoft YaHei"/>
                 <a:cs typeface="Microsoft YaHei"/>
               </a:rPr>
-              <a:t>避免位置配置污染其他模板</a:t>
+              <a:t>按模板版本发布</a:t>
             </a:r>
           </a:p>
         </p:txBody>
@@ -15991,334 +15991,6 @@
         </p:nvSpPr>
         <p:spPr>
           <a:xfrm>
-            <a:off x="502920" y="5422392"/>
-            <a:ext cx="1600200" cy="841248"/>
-          </a:xfrm>
-          <a:prstGeom prst="rect">
-            <a:avLst/>
-          </a:prstGeom>
-          <a:solidFill>
-            <a:srgbClr val="F5F7FA"/>
-          </a:solidFill>
-          <a:ln w="12700">
-            <a:solidFill>
-              <a:srgbClr val="CDD6E0"/>
-            </a:solidFill>
-          </a:ln>
-        </p:spPr>
-        <p:style>
-          <a:lnRef idx="1">
-            <a:schemeClr val="accent1"/>
-          </a:lnRef>
-          <a:fillRef idx="3">
-            <a:schemeClr val="accent1"/>
-          </a:fillRef>
-          <a:effectRef idx="2">
-            <a:schemeClr val="accent1"/>
-          </a:effectRef>
-          <a:fontRef idx="minor">
-            <a:schemeClr val="lt1"/>
-          </a:fontRef>
-        </p:style>
-        <p:txBody>
-          <a:bodyPr rtlCol="0" anchor="ctr"/>
-          <a:lstStyle/>
-          <a:p>
-            <a:pPr algn="ctr"/>
-          </a:p>
-        </p:txBody>
-      </p:sp>
-      <p:sp>
-        <p:nvSpPr>
-          <p:cNvPr id="40" name="TextBox 39"/>
-          <p:cNvSpPr txBox="1"/>
-          <p:nvPr/>
-        </p:nvSpPr>
-        <p:spPr>
-          <a:xfrm>
-            <a:off x="594360" y="5513831"/>
-            <a:ext cx="1435608" cy="731520"/>
-          </a:xfrm>
-          <a:prstGeom prst="rect">
-            <a:avLst/>
-          </a:prstGeom>
-          <a:noFill/>
-        </p:spPr>
-        <p:txBody>
-          <a:bodyPr wrap="square" lIns="27432" rIns="27432" tIns="18288" bIns="18288" anchor="t">
-            <a:spAutoFit/>
-          </a:bodyPr>
-          <a:lstStyle/>
-          <a:p>
-            <a:pPr algn="l"/>
-            <a:r>
-              <a:rPr sz="940" b="1">
-                <a:solidFill>
-                  <a:srgbClr val="17212F"/>
-                </a:solidFill>
-                <a:latin typeface="Microsoft YaHei"/>
-                <a:ea typeface="Microsoft YaHei"/>
-                <a:cs typeface="Microsoft YaHei"/>
-              </a:rPr>
-              <a:t>反馈优化</a:t>
-            </a:r>
-          </a:p>
-        </p:txBody>
-      </p:sp>
-      <p:sp>
-        <p:nvSpPr>
-          <p:cNvPr id="41" name="Rectangle 40"/>
-          <p:cNvSpPr/>
-          <p:nvPr/>
-        </p:nvSpPr>
-        <p:spPr>
-          <a:xfrm>
-            <a:off x="2103120" y="5422392"/>
-            <a:ext cx="3749039" cy="841248"/>
-          </a:xfrm>
-          <a:prstGeom prst="rect">
-            <a:avLst/>
-          </a:prstGeom>
-          <a:solidFill>
-            <a:srgbClr val="F5F7FA"/>
-          </a:solidFill>
-          <a:ln w="12700">
-            <a:solidFill>
-              <a:srgbClr val="CDD6E0"/>
-            </a:solidFill>
-          </a:ln>
-        </p:spPr>
-        <p:style>
-          <a:lnRef idx="1">
-            <a:schemeClr val="accent1"/>
-          </a:lnRef>
-          <a:fillRef idx="3">
-            <a:schemeClr val="accent1"/>
-          </a:fillRef>
-          <a:effectRef idx="2">
-            <a:schemeClr val="accent1"/>
-          </a:effectRef>
-          <a:fontRef idx="minor">
-            <a:schemeClr val="lt1"/>
-          </a:fontRef>
-        </p:style>
-        <p:txBody>
-          <a:bodyPr rtlCol="0" anchor="ctr"/>
-          <a:lstStyle/>
-          <a:p>
-            <a:pPr algn="ctr"/>
-          </a:p>
-        </p:txBody>
-      </p:sp>
-      <p:sp>
-        <p:nvSpPr>
-          <p:cNvPr id="42" name="TextBox 41"/>
-          <p:cNvSpPr txBox="1"/>
-          <p:nvPr/>
-        </p:nvSpPr>
-        <p:spPr>
-          <a:xfrm>
-            <a:off x="2194560" y="5513831"/>
-            <a:ext cx="3584447" cy="731520"/>
-          </a:xfrm>
-          <a:prstGeom prst="rect">
-            <a:avLst/>
-          </a:prstGeom>
-          <a:noFill/>
-        </p:spPr>
-        <p:txBody>
-          <a:bodyPr wrap="square" lIns="27432" rIns="27432" tIns="18288" bIns="18288" anchor="t">
-            <a:spAutoFit/>
-          </a:bodyPr>
-          <a:lstStyle/>
-          <a:p>
-            <a:pPr algn="l"/>
-            <a:r>
-              <a:rPr sz="940" b="0">
-                <a:solidFill>
-                  <a:srgbClr val="17212F"/>
-                </a:solidFill>
-                <a:latin typeface="Microsoft YaHei"/>
-                <a:ea typeface="Microsoft YaHei"/>
-                <a:cs typeface="Microsoft YaHei"/>
-              </a:rPr>
-              <a:t>下次调用模型时带入新叫法</a:t>
-            </a:r>
-          </a:p>
-        </p:txBody>
-      </p:sp>
-      <p:sp>
-        <p:nvSpPr>
-          <p:cNvPr id="43" name="Rectangle 42"/>
-          <p:cNvSpPr/>
-          <p:nvPr/>
-        </p:nvSpPr>
-        <p:spPr>
-          <a:xfrm>
-            <a:off x="5852159" y="5422392"/>
-            <a:ext cx="3840480" cy="841248"/>
-          </a:xfrm>
-          <a:prstGeom prst="rect">
-            <a:avLst/>
-          </a:prstGeom>
-          <a:solidFill>
-            <a:srgbClr val="F5F7FA"/>
-          </a:solidFill>
-          <a:ln w="12700">
-            <a:solidFill>
-              <a:srgbClr val="CDD6E0"/>
-            </a:solidFill>
-          </a:ln>
-        </p:spPr>
-        <p:style>
-          <a:lnRef idx="1">
-            <a:schemeClr val="accent1"/>
-          </a:lnRef>
-          <a:fillRef idx="3">
-            <a:schemeClr val="accent1"/>
-          </a:fillRef>
-          <a:effectRef idx="2">
-            <a:schemeClr val="accent1"/>
-          </a:effectRef>
-          <a:fontRef idx="minor">
-            <a:schemeClr val="lt1"/>
-          </a:fontRef>
-        </p:style>
-        <p:txBody>
-          <a:bodyPr rtlCol="0" anchor="ctr"/>
-          <a:lstStyle/>
-          <a:p>
-            <a:pPr algn="ctr"/>
-          </a:p>
-        </p:txBody>
-      </p:sp>
-      <p:sp>
-        <p:nvSpPr>
-          <p:cNvPr id="44" name="TextBox 43"/>
-          <p:cNvSpPr txBox="1"/>
-          <p:nvPr/>
-        </p:nvSpPr>
-        <p:spPr>
-          <a:xfrm>
-            <a:off x="5943599" y="5513831"/>
-            <a:ext cx="3675888" cy="731520"/>
-          </a:xfrm>
-          <a:prstGeom prst="rect">
-            <a:avLst/>
-          </a:prstGeom>
-          <a:noFill/>
-        </p:spPr>
-        <p:txBody>
-          <a:bodyPr wrap="square" lIns="27432" rIns="27432" tIns="18288" bIns="18288" anchor="t">
-            <a:spAutoFit/>
-          </a:bodyPr>
-          <a:lstStyle/>
-          <a:p>
-            <a:pPr algn="l"/>
-            <a:r>
-              <a:rPr sz="940" b="0">
-                <a:solidFill>
-                  <a:srgbClr val="17212F"/>
-                </a:solidFill>
-                <a:latin typeface="Microsoft YaHei"/>
-                <a:ea typeface="Microsoft YaHei"/>
-                <a:cs typeface="Microsoft YaHei"/>
-              </a:rPr>
-              <a:t>保存为模板别名或字段提示，支持回滚</a:t>
-            </a:r>
-          </a:p>
-        </p:txBody>
-      </p:sp>
-      <p:sp>
-        <p:nvSpPr>
-          <p:cNvPr id="45" name="Rectangle 44"/>
-          <p:cNvSpPr/>
-          <p:nvPr/>
-        </p:nvSpPr>
-        <p:spPr>
-          <a:xfrm>
-            <a:off x="9692640" y="5422392"/>
-            <a:ext cx="3246120" cy="841248"/>
-          </a:xfrm>
-          <a:prstGeom prst="rect">
-            <a:avLst/>
-          </a:prstGeom>
-          <a:solidFill>
-            <a:srgbClr val="F5F7FA"/>
-          </a:solidFill>
-          <a:ln w="12700">
-            <a:solidFill>
-              <a:srgbClr val="CDD6E0"/>
-            </a:solidFill>
-          </a:ln>
-        </p:spPr>
-        <p:style>
-          <a:lnRef idx="1">
-            <a:schemeClr val="accent1"/>
-          </a:lnRef>
-          <a:fillRef idx="3">
-            <a:schemeClr val="accent1"/>
-          </a:fillRef>
-          <a:effectRef idx="2">
-            <a:schemeClr val="accent1"/>
-          </a:effectRef>
-          <a:fontRef idx="minor">
-            <a:schemeClr val="lt1"/>
-          </a:fontRef>
-        </p:style>
-        <p:txBody>
-          <a:bodyPr rtlCol="0" anchor="ctr"/>
-          <a:lstStyle/>
-          <a:p>
-            <a:pPr algn="ctr"/>
-          </a:p>
-        </p:txBody>
-      </p:sp>
-      <p:sp>
-        <p:nvSpPr>
-          <p:cNvPr id="46" name="TextBox 45"/>
-          <p:cNvSpPr txBox="1"/>
-          <p:nvPr/>
-        </p:nvSpPr>
-        <p:spPr>
-          <a:xfrm>
-            <a:off x="9784080" y="5513831"/>
-            <a:ext cx="3081527" cy="731520"/>
-          </a:xfrm>
-          <a:prstGeom prst="rect">
-            <a:avLst/>
-          </a:prstGeom>
-          <a:noFill/>
-        </p:spPr>
-        <p:txBody>
-          <a:bodyPr wrap="square" lIns="27432" rIns="27432" tIns="18288" bIns="18288" anchor="t">
-            <a:spAutoFit/>
-          </a:bodyPr>
-          <a:lstStyle/>
-          <a:p>
-            <a:pPr algn="l"/>
-            <a:r>
-              <a:rPr sz="940" b="0">
-                <a:solidFill>
-                  <a:srgbClr val="17212F"/>
-                </a:solidFill>
-                <a:latin typeface="Microsoft YaHei"/>
-                <a:ea typeface="Microsoft YaHei"/>
-                <a:cs typeface="Microsoft YaHei"/>
-              </a:rPr>
-              <a:t>按模板版本发布</a:t>
-            </a:r>
-          </a:p>
-        </p:txBody>
-      </p:sp>
-      <p:sp>
-        <p:nvSpPr>
-          <p:cNvPr id="47" name="Rectangle 46"/>
-          <p:cNvSpPr/>
-          <p:nvPr/>
-        </p:nvSpPr>
-        <p:spPr>
-          <a:xfrm>
             <a:off x="502920" y="7452360"/>
             <a:ext cx="64008" cy="502920"/>
           </a:xfrm>
@@ -16358,7 +16030,7 @@
       </p:sp>
       <p:sp>
         <p:nvSpPr>
-          <p:cNvPr id="48" name="TextBox 47"/>
+          <p:cNvPr id="40" name="TextBox 39"/>
           <p:cNvSpPr txBox="1"/>
           <p:nvPr/>
         </p:nvSpPr>
@@ -16395,7 +16067,7 @@
       </p:sp>
       <p:sp>
         <p:nvSpPr>
-          <p:cNvPr id="49" name="TextBox 48"/>
+          <p:cNvPr id="41" name="TextBox 40"/>
           <p:cNvSpPr txBox="1"/>
           <p:nvPr/>
         </p:nvSpPr>
@@ -16432,7 +16104,7 @@
       </p:sp>
       <p:sp>
         <p:nvSpPr>
-          <p:cNvPr id="50" name="TextBox 49"/>
+          <p:cNvPr id="42" name="TextBox 41"/>
           <p:cNvSpPr txBox="1"/>
           <p:nvPr/>
         </p:nvSpPr>
@@ -17745,7 +17417,7 @@
                 <a:ea typeface="Microsoft YaHei"/>
                 <a:cs typeface="Microsoft YaHei"/>
               </a:rPr>
-              <a:t>新增/复制模板，增删改字段，维护别名、位置提示、提取要求</a:t>
+              <a:t>新增/复制模板，增删改字段，维护票面别名和给 AI 的输入</a:t>
             </a:r>
           </a:p>
         </p:txBody>

</xml_diff>

<commit_message>
chore: rename AI instruction display
</commit_message>
<xml_diff>
--- a/docs/business-overview-deck/output/bill_verification_business_overview_editable.pptx
+++ b/docs/business-overview-deck/output/bill_verification_business_overview_editable.pptx
@@ -4681,7 +4681,7 @@
                 <a:ea typeface="Microsoft YaHei"/>
                 <a:cs typeface="Microsoft YaHei"/>
               </a:rPr>
-              <a:t>模板新增/复制、字段增删改、票面别名、给 AI 的输入、反馈样本</a:t>
+              <a:t>模板新增/复制、字段增删改、票面别名、AI 识别说明、反馈样本</a:t>
             </a:r>
           </a:p>
         </p:txBody>
@@ -7887,7 +7887,7 @@
                 <a:ea typeface="Microsoft YaHei"/>
                 <a:cs typeface="Microsoft YaHei"/>
               </a:rPr>
-              <a:t>待检查字段、系统来源、票面别名、给 AI 的输入</a:t>
+              <a:t>待检查字段、系统来源、票面别名、AI 识别说明</a:t>
             </a:r>
           </a:p>
         </p:txBody>
@@ -10638,7 +10638,7 @@
                 <a:ea typeface="Microsoft YaHei"/>
                 <a:cs typeface="Microsoft YaHei"/>
               </a:rPr>
-              <a:t>模板字段、系统来源、票面别名、给 AI 的输入</a:t>
+              <a:t>模板字段、系统来源、票面别名、AI 识别说明</a:t>
             </a:r>
           </a:p>
         </p:txBody>
@@ -15404,7 +15404,7 @@
                 <a:ea typeface="Microsoft YaHei"/>
                 <a:cs typeface="Microsoft YaHei"/>
               </a:rPr>
-              <a:t>给 AI 的输入</a:t>
+              <a:t>AI 识别说明</a:t>
             </a:r>
           </a:p>
         </p:txBody>
@@ -15896,7 +15896,7 @@
                 <a:ea typeface="Microsoft YaHei"/>
                 <a:cs typeface="Microsoft YaHei"/>
               </a:rPr>
-              <a:t>保存为模板别名或 AI 输入建议，支持回滚</a:t>
+              <a:t>保存为模板别名或 AI 识别说明建议，支持回滚</a:t>
             </a:r>
           </a:p>
         </p:txBody>
@@ -17417,7 +17417,7 @@
                 <a:ea typeface="Microsoft YaHei"/>
                 <a:cs typeface="Microsoft YaHei"/>
               </a:rPr>
-              <a:t>新增/复制模板，增删改字段，维护票面别名和给 AI 的输入</a:t>
+              <a:t>新增/复制模板，增删改字段，维护票面别名和 AI 识别说明</a:t>
             </a:r>
           </a:p>
         </p:txBody>

</xml_diff>